<commit_message>
Align Session 3 with Flink Bronze design and Iceberg commits
</commit_message>
<xml_diff>
--- a/labs/session03/slides/03-session03.pptx
+++ b/labs/session03/slides/03-session03.pptx
@@ -2,35 +2,35 @@
 <file path=ppt/presentation.xml><?xml version="1.0" encoding="utf-8"?>
 <p:presentation xmlns:p="http://schemas.openxmlformats.org/presentationml/2006/main">
   <p:sldMasterIdLst>
-    <p:sldMasterId xmlns:r="http://schemas.openxmlformats.org/officeDocument/2006/relationships" id="2147483648" r:id="R2d29c7fefb6940ca"/>
+    <p:sldMasterId xmlns:r="http://schemas.openxmlformats.org/officeDocument/2006/relationships" id="2147483648" r:id="R9d948e763b9f4419"/>
   </p:sldMasterIdLst>
   <p:notesMasterIdLst>
-    <p:notesMasterId xmlns:r="http://schemas.openxmlformats.org/officeDocument/2006/relationships" r:id="Rd12189f938c14a11"/>
+    <p:notesMasterId xmlns:r="http://schemas.openxmlformats.org/officeDocument/2006/relationships" r:id="R1f51776619684d0d"/>
   </p:notesMasterIdLst>
   <p:sldIdLst>
-    <p:sldId xmlns:r="http://schemas.openxmlformats.org/officeDocument/2006/relationships" id="256" r:id="Rb7f44be27d6b482b"/>
-    <p:sldId xmlns:r="http://schemas.openxmlformats.org/officeDocument/2006/relationships" id="257" r:id="R6d0b8239fbe14945"/>
-    <p:sldId xmlns:r="http://schemas.openxmlformats.org/officeDocument/2006/relationships" id="258" r:id="Rd6a71b0b5a074fe1"/>
-    <p:sldId xmlns:r="http://schemas.openxmlformats.org/officeDocument/2006/relationships" id="259" r:id="R996282ea4d99476e"/>
-    <p:sldId xmlns:r="http://schemas.openxmlformats.org/officeDocument/2006/relationships" id="260" r:id="Ree56e910458740a1"/>
-    <p:sldId xmlns:r="http://schemas.openxmlformats.org/officeDocument/2006/relationships" id="261" r:id="Rda98d47ca6c94389"/>
-    <p:sldId xmlns:r="http://schemas.openxmlformats.org/officeDocument/2006/relationships" id="262" r:id="R751a3a6ee4364561"/>
-    <p:sldId xmlns:r="http://schemas.openxmlformats.org/officeDocument/2006/relationships" id="263" r:id="R6d56e90649ae4410"/>
-    <p:sldId xmlns:r="http://schemas.openxmlformats.org/officeDocument/2006/relationships" id="264" r:id="Rd2203fb09fd94ab0"/>
-    <p:sldId xmlns:r="http://schemas.openxmlformats.org/officeDocument/2006/relationships" id="265" r:id="R0994f2705f2543f8"/>
-    <p:sldId xmlns:r="http://schemas.openxmlformats.org/officeDocument/2006/relationships" id="266" r:id="R25080eb04904465f"/>
-    <p:sldId xmlns:r="http://schemas.openxmlformats.org/officeDocument/2006/relationships" id="267" r:id="R2a046bd508514654"/>
-    <p:sldId xmlns:r="http://schemas.openxmlformats.org/officeDocument/2006/relationships" id="268" r:id="Re01a007e2baf43ee"/>
-    <p:sldId xmlns:r="http://schemas.openxmlformats.org/officeDocument/2006/relationships" id="269" r:id="R89125c9ff3834022"/>
-    <p:sldId xmlns:r="http://schemas.openxmlformats.org/officeDocument/2006/relationships" id="270" r:id="R5fb34fef84bb4958"/>
-    <p:sldId xmlns:r="http://schemas.openxmlformats.org/officeDocument/2006/relationships" id="271" r:id="R451f5b8202c943d6"/>
-    <p:sldId xmlns:r="http://schemas.openxmlformats.org/officeDocument/2006/relationships" id="272" r:id="Ra6a3cc9526e04dd1"/>
-    <p:sldId xmlns:r="http://schemas.openxmlformats.org/officeDocument/2006/relationships" id="273" r:id="R5af6521cd234470c"/>
-    <p:sldId xmlns:r="http://schemas.openxmlformats.org/officeDocument/2006/relationships" id="274" r:id="R09ab3c53cb5f44b2"/>
-    <p:sldId xmlns:r="http://schemas.openxmlformats.org/officeDocument/2006/relationships" id="275" r:id="Re4e623a3c05741c5"/>
-    <p:sldId xmlns:r="http://schemas.openxmlformats.org/officeDocument/2006/relationships" id="276" r:id="Rab2f8597e23e4f95"/>
-    <p:sldId xmlns:r="http://schemas.openxmlformats.org/officeDocument/2006/relationships" id="277" r:id="R3d6004ebe3d64d63"/>
-    <p:sldId xmlns:r="http://schemas.openxmlformats.org/officeDocument/2006/relationships" id="278" r:id="Rb566a3c5818146e1"/>
+    <p:sldId xmlns:r="http://schemas.openxmlformats.org/officeDocument/2006/relationships" id="256" r:id="R4726fc0cee394f7b"/>
+    <p:sldId xmlns:r="http://schemas.openxmlformats.org/officeDocument/2006/relationships" id="257" r:id="Rebb2a40204c648ec"/>
+    <p:sldId xmlns:r="http://schemas.openxmlformats.org/officeDocument/2006/relationships" id="258" r:id="R55af6b1cfa934194"/>
+    <p:sldId xmlns:r="http://schemas.openxmlformats.org/officeDocument/2006/relationships" id="259" r:id="R162bcdd3d72544c4"/>
+    <p:sldId xmlns:r="http://schemas.openxmlformats.org/officeDocument/2006/relationships" id="260" r:id="R1d7ddc1bc9f1435f"/>
+    <p:sldId xmlns:r="http://schemas.openxmlformats.org/officeDocument/2006/relationships" id="261" r:id="R91cc0c31da9743be"/>
+    <p:sldId xmlns:r="http://schemas.openxmlformats.org/officeDocument/2006/relationships" id="262" r:id="R44642b56e87d4b8e"/>
+    <p:sldId xmlns:r="http://schemas.openxmlformats.org/officeDocument/2006/relationships" id="263" r:id="Ref08b28a349a4b3c"/>
+    <p:sldId xmlns:r="http://schemas.openxmlformats.org/officeDocument/2006/relationships" id="264" r:id="R5ab301715fe242e5"/>
+    <p:sldId xmlns:r="http://schemas.openxmlformats.org/officeDocument/2006/relationships" id="265" r:id="R2e28e158196c46b7"/>
+    <p:sldId xmlns:r="http://schemas.openxmlformats.org/officeDocument/2006/relationships" id="266" r:id="Rd7e1596e675840a1"/>
+    <p:sldId xmlns:r="http://schemas.openxmlformats.org/officeDocument/2006/relationships" id="267" r:id="Rc1c4d22b2f6f40cc"/>
+    <p:sldId xmlns:r="http://schemas.openxmlformats.org/officeDocument/2006/relationships" id="268" r:id="R7b66ca3dce234495"/>
+    <p:sldId xmlns:r="http://schemas.openxmlformats.org/officeDocument/2006/relationships" id="269" r:id="R1e0073cee5764cce"/>
+    <p:sldId xmlns:r="http://schemas.openxmlformats.org/officeDocument/2006/relationships" id="270" r:id="Raa6184025fe34aff"/>
+    <p:sldId xmlns:r="http://schemas.openxmlformats.org/officeDocument/2006/relationships" id="271" r:id="Rc39c68c1630e4866"/>
+    <p:sldId xmlns:r="http://schemas.openxmlformats.org/officeDocument/2006/relationships" id="272" r:id="R40ac7bbc6cc249cf"/>
+    <p:sldId xmlns:r="http://schemas.openxmlformats.org/officeDocument/2006/relationships" id="273" r:id="R6e4e4879440543fd"/>
+    <p:sldId xmlns:r="http://schemas.openxmlformats.org/officeDocument/2006/relationships" id="274" r:id="R87ff175dc1944568"/>
+    <p:sldId xmlns:r="http://schemas.openxmlformats.org/officeDocument/2006/relationships" id="275" r:id="R2275eb3f58d346b8"/>
+    <p:sldId xmlns:r="http://schemas.openxmlformats.org/officeDocument/2006/relationships" id="276" r:id="R2d11e821beff495e"/>
+    <p:sldId xmlns:r="http://schemas.openxmlformats.org/officeDocument/2006/relationships" id="277" r:id="Reba1c2779f014dcd"/>
+    <p:sldId xmlns:r="http://schemas.openxmlformats.org/officeDocument/2006/relationships" id="278" r:id="Rb6eb138ff120457b"/>
   </p:sldIdLst>
   <p:sldSz cx="12192000" cy="6858000"/>
   <p:notesSz cx="6858000" cy="9144000"/>
@@ -4447,12 +4447,12 @@
   </p:cSld>
   <p:clrMap bg1="lt1" tx1="dk1" bg2="lt2" tx2="dk2" accent1="accent1" accent2="accent2" accent3="accent3" accent4="accent4" accent5="accent5" accent6="accent6" hlink="hlink" folHlink="folHlink"/>
   <p:sldLayoutIdLst>
-    <p:sldLayoutId xmlns:r="http://schemas.openxmlformats.org/officeDocument/2006/relationships" id="2147483649" r:id="R5135b756c3864f27"/>
-    <p:sldLayoutId xmlns:r="http://schemas.openxmlformats.org/officeDocument/2006/relationships" id="2147483650" r:id="Rf9c34c4518a34d1c"/>
-    <p:sldLayoutId xmlns:r="http://schemas.openxmlformats.org/officeDocument/2006/relationships" id="2147483651" r:id="R7b38944dabcf4bb1"/>
-    <p:sldLayoutId xmlns:r="http://schemas.openxmlformats.org/officeDocument/2006/relationships" id="2147483652" r:id="R6d7fca1670c24f09"/>
-    <p:sldLayoutId xmlns:r="http://schemas.openxmlformats.org/officeDocument/2006/relationships" id="2147483653" r:id="R48d2387f887744ee"/>
-    <p:sldLayoutId xmlns:r="http://schemas.openxmlformats.org/officeDocument/2006/relationships" id="2147483654" r:id="Rcb879037785f4e81"/>
+    <p:sldLayoutId xmlns:r="http://schemas.openxmlformats.org/officeDocument/2006/relationships" id="2147483649" r:id="Rf3c7486bedbb4b9e"/>
+    <p:sldLayoutId xmlns:r="http://schemas.openxmlformats.org/officeDocument/2006/relationships" id="2147483650" r:id="R13b18b0ec5cc4aa3"/>
+    <p:sldLayoutId xmlns:r="http://schemas.openxmlformats.org/officeDocument/2006/relationships" id="2147483651" r:id="Rbdfa62d5aae84224"/>
+    <p:sldLayoutId xmlns:r="http://schemas.openxmlformats.org/officeDocument/2006/relationships" id="2147483652" r:id="R529dafd057e34949"/>
+    <p:sldLayoutId xmlns:r="http://schemas.openxmlformats.org/officeDocument/2006/relationships" id="2147483653" r:id="Rbd77eb5925644439"/>
+    <p:sldLayoutId xmlns:r="http://schemas.openxmlformats.org/officeDocument/2006/relationships" id="2147483654" r:id="Rd663b1a932704d6f"/>
   </p:sldLayoutIdLst>
   <p:txStyles>
     <p:titleStyle>
@@ -5329,7 +5329,7 @@
                 <a:ea typeface="Apple SD Gothic Neo"/>
                 <a:cs typeface="Apple SD Gothic Neo"/>
               </a:rPr>
-              <a:t>변경 데이터를 다루는</a:t>
+              <a:t>Flink → Bronze 적재 심화</a:t>
             </a:r>
           </a:p>
           <a:p xmlns:a="http://schemas.openxmlformats.org/drawingml/2006/main">
@@ -5353,7 +5353,7 @@
                 <a:ea typeface="Apple SD Gothic Neo"/>
                 <a:cs typeface="Apple SD Gothic Neo"/>
               </a:rPr>
-              <a:t>파이프라인 설계</a:t>
+              <a:t>개인 도메인·테이블 설계 확정</a:t>
             </a:r>
           </a:p>
         </p:txBody>
@@ -5551,7 +5551,7 @@
                 <a:ea typeface="Apple SD Gothic Neo"/>
                 <a:cs typeface="Apple SD Gothic Neo"/>
               </a:rPr>
-              <a:t>3회차 · 120분</a:t>
+              <a:t>적재 SQL과 조회 결과를 연결하고</a:t>
             </a:r>
           </a:p>
           <a:p xmlns:a="http://schemas.openxmlformats.org/drawingml/2006/main">
@@ -5575,7 +5575,7 @@
                 <a:ea typeface="Apple SD Gothic Neo"/>
                 <a:cs typeface="Apple SD Gothic Neo"/>
               </a:rPr>
-              <a:t>요구사항을 정하고, 짧은 실험으로 설계 판단하기</a:t>
+              <a:t>내 도메인·테이블 설계를 확정합니다</a:t>
             </a:r>
           </a:p>
         </p:txBody>
@@ -5743,7 +5743,7 @@
                 <a:ea typeface="Apple SD Gothic Neo"/>
                 <a:cs typeface="Apple SD Gothic Neo"/>
               </a:rPr>
-              <a:t>요구사항과 설계 선택 · 짧은 실험 · 내 프로젝트 설계</a:t>
+              <a:t>Flink 적재 설계 · Iceberg 구조와 커밋 · 개인 도메인·테이블 확정</a:t>
             </a:r>
           </a:p>
         </p:txBody>
@@ -6474,7 +6474,7 @@
                 <a:ea typeface="Apple SD Gothic Neo"/>
                 <a:cs typeface="Apple SD Gothic Neo"/>
               </a:rPr>
-              <a:t>복구 상태와 테이블 조회의 경계</a:t>
+              <a:t>파일 저장과 테이블 커밋은 다릅니다</a:t>
             </a:r>
           </a:p>
         </p:txBody>
@@ -6850,7 +6850,7 @@
           <p:cNvPr id="10" name="">
             <a:extLst xmlns:a="http://schemas.openxmlformats.org/drawingml/2006/main">
               <a:ext uri="{FF2B5EF4-FFF2-40B4-BE49-F238E27FC236}">
-                <a16:creationId xmlns:a16="http://schemas.microsoft.com/office/drawing/2014/main" id="{E06FAC5C-C468-4682-8681-F5FECAD84B2A}"/>
+                <a16:creationId xmlns:a16="http://schemas.microsoft.com/office/drawing/2014/main" id="{BCD3B270-5F0A-44CC-AFB0-C56718C41569}"/>
               </a:ext>
             </a:extLst>
           </p:cNvPr>
@@ -6884,7 +6884,7 @@
                           <a:ea typeface="Apple SD Gothic Neo"/>
                           <a:cs typeface="Apple SD Gothic Neo"/>
                         </a:rPr>
-                        <a:t>관찰</a:t>
+                        <a:t>단계</a:t>
                       </a:r>
                     </a:p>
                   </a:txBody>
@@ -6932,7 +6932,7 @@
                           <a:ea typeface="Apple SD Gothic Neo"/>
                           <a:cs typeface="Apple SD Gothic Neo"/>
                         </a:rPr>
-                        <a:t>확인하는 범위</a:t>
+                        <a:t>테이블에서 읽는 상태</a:t>
                       </a:r>
                     </a:p>
                   </a:txBody>
@@ -6976,7 +6976,7 @@
                           <a:ea typeface="Apple SD Gothic Neo"/>
                           <a:cs typeface="Apple SD Gothic Neo"/>
                         </a:rPr>
-                        <a:t>Flink checkpoint</a:t>
+                        <a:t>새 파일 준비</a:t>
                       </a:r>
                     </a:p>
                   </a:txBody>
@@ -7018,7 +7018,7 @@
                           <a:ea typeface="Apple SD Gothic Neo"/>
                           <a:cs typeface="Apple SD Gothic Neo"/>
                         </a:rPr>
-                        <a:t>처리 위치·상태의 복구 지점</a:t>
+                        <a:t>새 Parquet·메타데이터 작성 · 커밋 전 참조는 그대로</a:t>
                       </a:r>
                     </a:p>
                   </a:txBody>
@@ -7056,7 +7056,7 @@
                           <a:ea typeface="Apple SD Gothic Neo"/>
                           <a:cs typeface="Apple SD Gothic Neo"/>
                         </a:rPr>
-                        <a:t>Iceberg snapshot / commit</a:t>
+                        <a:t>Iceberg commit</a:t>
                       </a:r>
                     </a:p>
                   </a:txBody>
@@ -7098,7 +7098,7 @@
                           <a:ea typeface="Apple SD Gothic Neo"/>
                           <a:cs typeface="Apple SD Gothic Neo"/>
                         </a:rPr>
-                        <a:t>테이블이 참조하는 저장 상태</a:t>
+                        <a:t>Catalog의 현재 메타데이터 참조를 원자적으로 갱신</a:t>
                       </a:r>
                     </a:p>
                   </a:txBody>
@@ -7136,7 +7136,7 @@
                           <a:ea typeface="Apple SD Gothic Neo"/>
                           <a:cs typeface="Apple SD Gothic Neo"/>
                         </a:rPr>
-                        <a:t>같은 키의 SELECT</a:t>
+                        <a:t>조회로 확인</a:t>
                       </a:r>
                     </a:p>
                   </a:txBody>
@@ -7178,7 +7178,7 @@
                           <a:ea typeface="Apple SD Gothic Neo"/>
                           <a:cs typeface="Apple SD Gothic Neo"/>
                         </a:rPr>
-                        <a:t>확인하려는 변경이 실제로 읽히는가</a:t>
+                        <a:t>새 조회의 같은 키 SELECT로 해당 변경 확인</a:t>
                       </a:r>
                     </a:p>
                   </a:txBody>
@@ -7402,7 +7402,7 @@
                 <a:ea typeface="Apple SD Gothic Neo"/>
                 <a:cs typeface="Apple SD Gothic Neo"/>
               </a:rPr>
-              <a:t>checkpoint ID와 snapshot ID를 일대일로 맞추지 않습니다</a:t>
+              <a:t>checkpoint는 복구 지점 · commit은 테이블 상태 갱신 · ID는 다릅니다</a:t>
             </a:r>
           </a:p>
         </p:txBody>
@@ -10763,7 +10763,7 @@
           <p:cNvPr id="10" name="">
             <a:extLst xmlns:a="http://schemas.openxmlformats.org/drawingml/2006/main">
               <a:ext uri="{FF2B5EF4-FFF2-40B4-BE49-F238E27FC236}">
-                <a16:creationId xmlns:a16="http://schemas.microsoft.com/office/drawing/2014/main" id="{7E1ED67C-361D-40D6-9526-1FA57683EDB9}"/>
+                <a16:creationId xmlns:a16="http://schemas.microsoft.com/office/drawing/2014/main" id="{BB6F0EB0-E1A4-46FA-9CB2-53E0414A44A5}"/>
               </a:ext>
             </a:extLst>
           </p:cNvPr>
@@ -18395,7 +18395,7 @@
           <p:cNvPr id="10" name="">
             <a:extLst xmlns:a="http://schemas.openxmlformats.org/drawingml/2006/main">
               <a:ext uri="{FF2B5EF4-FFF2-40B4-BE49-F238E27FC236}">
-                <a16:creationId xmlns:a16="http://schemas.microsoft.com/office/drawing/2014/main" id="{1B277252-C492-4082-BE01-54D10568B690}"/>
+                <a16:creationId xmlns:a16="http://schemas.microsoft.com/office/drawing/2014/main" id="{CA2AA05E-CDB6-43CC-8A06-AACD7B527C3A}"/>
               </a:ext>
             </a:extLst>
           </p:cNvPr>
@@ -19347,7 +19347,7 @@
                 <a:ea typeface="Apple SD Gothic Neo"/>
                 <a:cs typeface="Apple SD Gothic Neo"/>
               </a:rPr>
-              <a:t>개인 설계 초안의 빈칸 점검</a:t>
+              <a:t>개인 도메인·테이블 설계 확정</a:t>
             </a:r>
           </a:p>
         </p:txBody>
@@ -19549,7 +19549,7 @@
                 <a:ea typeface="Apple SD Gothic Neo"/>
                 <a:cs typeface="Apple SD Gothic Neo"/>
               </a:rPr>
-              <a:t>지금 있는 초안</a:t>
+              <a:t>앞에서 정한 것</a:t>
             </a:r>
           </a:p>
         </p:txBody>
@@ -19717,7 +19717,7 @@
                 <a:ea typeface="Apple SD Gothic Neo"/>
                 <a:cs typeface="Apple SD Gothic Neo"/>
               </a:rPr>
-              <a:t>업무 질문·지연 목표</a:t>
+              <a:t>업무 질문·두 지연 목표</a:t>
             </a:r>
           </a:p>
           <a:p xmlns:a="http://schemas.openxmlformats.org/drawingml/2006/main">
@@ -19741,7 +19741,7 @@
                 <a:ea typeface="Apple SD Gothic Neo"/>
                 <a:cs typeface="Apple SD Gothic Neo"/>
               </a:rPr>
-              <a:t>수집과 저장의 선택</a:t>
+              <a:t>Flink 입력과 Bronze 적재 책임</a:t>
             </a:r>
           </a:p>
         </p:txBody>
@@ -19943,7 +19943,7 @@
                 <a:ea typeface="Apple SD Gothic Neo"/>
                 <a:cs typeface="Apple SD Gothic Neo"/>
               </a:rPr>
-              <a:t>이제 보완할 것</a:t>
+              <a:t>30분 동안 확정</a:t>
             </a:r>
           </a:p>
         </p:txBody>
@@ -20111,7 +20111,7 @@
                 <a:ea typeface="Apple SD Gothic Neo"/>
                 <a:cs typeface="Apple SD Gothic Neo"/>
               </a:rPr>
-              <a:t>테이블과 관계</a:t>
+              <a:t>도메인·원천 테이블·PK/FK</a:t>
             </a:r>
           </a:p>
           <a:p xmlns:a="http://schemas.openxmlformats.org/drawingml/2006/main">
@@ -20135,7 +20135,7 @@
                 <a:ea typeface="Apple SD Gothic Neo"/>
                 <a:cs typeface="Apple SD Gothic Neo"/>
               </a:rPr>
-              <a:t>변경 사례와 기대값</a:t>
+              <a:t>변경 의미와 Bronze 보존 정보</a:t>
             </a:r>
           </a:p>
         </p:txBody>
@@ -20337,7 +20337,7 @@
                 <a:ea typeface="Apple SD Gothic Neo"/>
                 <a:cs typeface="Apple SD Gothic Neo"/>
               </a:rPr>
-              <a:t>개인 설계 보완 30분 · 구현은 수업 사이에 이어갑니다</a:t>
+              <a:t>도메인·테이블은 오늘 확정합니다 · DDL 구현은 수업 사이에 이어갑니다</a:t>
             </a:r>
           </a:p>
         </p:txBody>
@@ -21068,7 +21068,7 @@
                 <a:ea typeface="Apple SD Gothic Neo"/>
                 <a:cs typeface="Apple SD Gothic Neo"/>
               </a:rPr>
-              <a:t>원천 테이블과 변경 사례 보완</a:t>
+              <a:t>원천 테이블과 변경 의미 확정</a:t>
             </a:r>
           </a:p>
         </p:txBody>
@@ -21444,7 +21444,7 @@
           <p:cNvPr id="10" name="">
             <a:extLst xmlns:a="http://schemas.openxmlformats.org/drawingml/2006/main">
               <a:ext uri="{FF2B5EF4-FFF2-40B4-BE49-F238E27FC236}">
-                <a16:creationId xmlns:a16="http://schemas.microsoft.com/office/drawing/2014/main" id="{E4C45D74-6AC9-4909-BE7F-FDB96D00150F}"/>
+                <a16:creationId xmlns:a16="http://schemas.microsoft.com/office/drawing/2014/main" id="{33CD16BC-0A8A-4648-B4A3-8501FA2FB6EB}"/>
               </a:ext>
             </a:extLst>
           </p:cNvPr>
@@ -22076,7 +22076,7 @@
                 <a:ea typeface="Apple SD Gothic Neo"/>
                 <a:cs typeface="Apple SD Gothic Neo"/>
               </a:rPr>
-              <a:t>학습지 3번 · 선택한 도메인의 실제 값으로 작성합니다</a:t>
+              <a:t>학습지 3번: 테이블명·한 행의 의미·PK/FK·변경 사례를 확정합니다</a:t>
             </a:r>
           </a:p>
         </p:txBody>
@@ -22817,7 +22817,7 @@
           <p:cNvPr id="8" name="">
             <a:extLst xmlns:a="http://schemas.openxmlformats.org/drawingml/2006/main">
               <a:ext uri="{FF2B5EF4-FFF2-40B4-BE49-F238E27FC236}">
-                <a16:creationId xmlns:a16="http://schemas.microsoft.com/office/drawing/2014/main" id="{A50120E1-5657-4A9B-92DC-2294CB3702A9}"/>
+                <a16:creationId xmlns:a16="http://schemas.microsoft.com/office/drawing/2014/main" id="{ABDF4E32-3B9D-4D0F-8076-C7B08930A6AC}"/>
               </a:ext>
             </a:extLst>
           </p:cNvPr>
@@ -23260,7 +23260,7 @@
                           <a:ea typeface="Apple SD Gothic Neo"/>
                           <a:cs typeface="Apple SD Gothic Neo"/>
                         </a:rPr>
-                        <a:t>수집과 저장 구조</a:t>
+                        <a:t>Flink 적재·Iceberg 구조</a:t>
                       </a:r>
                     </a:p>
                   </a:txBody>
@@ -23296,7 +23296,7 @@
                           <a:ea typeface="Apple SD Gothic Neo"/>
                           <a:cs typeface="Apple SD Gothic Neo"/>
                         </a:rPr>
-                        <a:t>대안 비교와 책임 분리</a:t>
+                        <a:t>원문·메타데이터·append</a:t>
                       </a:r>
                     </a:p>
                   </a:txBody>
@@ -23376,7 +23376,7 @@
                           <a:ea typeface="Apple SD Gothic Neo"/>
                           <a:cs typeface="Apple SD Gothic Neo"/>
                         </a:rPr>
-                        <a:t>처리·조회 경계와 휴식</a:t>
+                        <a:t>테이블 커밋과 휴식</a:t>
                       </a:r>
                     </a:p>
                   </a:txBody>
@@ -23412,7 +23412,7 @@
                           <a:ea typeface="Apple SD Gothic Neo"/>
                           <a:cs typeface="Apple SD Gothic Neo"/>
                         </a:rPr>
-                        <a:t>checkpoint·commit</a:t>
+                        <a:t>파일 저장·조회 시점 구분</a:t>
                       </a:r>
                     </a:p>
                   </a:txBody>
@@ -23608,7 +23608,7 @@
                           <a:ea typeface="Apple SD Gothic Neo"/>
                           <a:cs typeface="Apple SD Gothic Neo"/>
                         </a:rPr>
-                        <a:t>개인 설계 보완</a:t>
+                        <a:t>개인 도메인·테이블 확정</a:t>
                       </a:r>
                     </a:p>
                   </a:txBody>
@@ -23644,7 +23644,7 @@
                           <a:ea typeface="Apple SD Gothic Neo"/>
                           <a:cs typeface="Apple SD Gothic Neo"/>
                         </a:rPr>
-                        <a:t>테이블·변경·기대값</a:t>
+                        <a:t>테이블·키·변경·적재 책임</a:t>
                       </a:r>
                     </a:p>
                   </a:txBody>
@@ -28469,7 +28469,7 @@
                 <a:ea typeface="Apple SD Gothic Neo"/>
                 <a:cs typeface="Apple SD Gothic Neo"/>
               </a:rPr>
-              <a:t>결정한 것과 다음에 구현할 것</a:t>
+              <a:t>확정한 설계와 다음 구현</a:t>
             </a:r>
           </a:p>
         </p:txBody>
@@ -28671,7 +28671,7 @@
                 <a:ea typeface="Apple SD Gothic Neo"/>
                 <a:cs typeface="Apple SD Gothic Neo"/>
               </a:rPr>
-              <a:t>결정</a:t>
+              <a:t>오늘 확정</a:t>
             </a:r>
           </a:p>
         </p:txBody>
@@ -28863,7 +28863,7 @@
                 <a:ea typeface="Apple SD Gothic Neo"/>
                 <a:cs typeface="Apple SD Gothic Neo"/>
               </a:rPr>
-              <a:t>수정과 삭제 의미</a:t>
+              <a:t>변경 의미와 Bronze 적재 책임</a:t>
             </a:r>
           </a:p>
         </p:txBody>
@@ -30960,7 +30960,7 @@
           <p:cNvPr id="9" name="">
             <a:extLst xmlns:a="http://schemas.openxmlformats.org/drawingml/2006/main">
               <a:ext uri="{FF2B5EF4-FFF2-40B4-BE49-F238E27FC236}">
-                <a16:creationId xmlns:a16="http://schemas.microsoft.com/office/drawing/2014/main" id="{5691B446-038C-464D-A779-8B8A57D8E250}"/>
+                <a16:creationId xmlns:a16="http://schemas.microsoft.com/office/drawing/2014/main" id="{E82E91D3-139C-4269-BCD4-585539793F57}"/>
               </a:ext>
             </a:extLst>
           </p:cNvPr>
@@ -31246,7 +31246,7 @@
                           <a:ea typeface="Apple SD Gothic Neo"/>
                           <a:cs typeface="Apple SD Gothic Neo"/>
                         </a:rPr>
-                        <a:t>수집 선택</a:t>
+                        <a:t>Flink 입력·적재</a:t>
                       </a:r>
                     </a:p>
                   </a:txBody>
@@ -31288,7 +31288,7 @@
                           <a:ea typeface="Apple SD Gothic Neo"/>
                           <a:cs typeface="Apple SD Gothic Neo"/>
                         </a:rPr>
-                        <a:t>PostgreSQL · Debezium · Kafka</a:t>
+                        <a:t>Raw format · Kafka metadata · append</a:t>
                       </a:r>
                     </a:p>
                   </a:txBody>
@@ -31368,7 +31368,7 @@
                           <a:ea typeface="Apple SD Gothic Neo"/>
                           <a:cs typeface="Apple SD Gothic Neo"/>
                         </a:rPr>
-                        <a:t>Flink checkpoint · Iceberg writes/snapshots</a:t>
+                        <a:t>Flink checkpoint · Iceberg 구조·commit</a:t>
                       </a:r>
                     </a:p>
                   </a:txBody>
@@ -36529,7 +36529,7 @@
           <p:cNvPr id="10" name="">
             <a:extLst xmlns:a="http://schemas.openxmlformats.org/drawingml/2006/main">
               <a:ext uri="{FF2B5EF4-FFF2-40B4-BE49-F238E27FC236}">
-                <a16:creationId xmlns:a16="http://schemas.microsoft.com/office/drawing/2014/main" id="{28D5E151-BDE1-4E90-9C04-38881AE7B833}"/>
+                <a16:creationId xmlns:a16="http://schemas.microsoft.com/office/drawing/2014/main" id="{BDB84647-446F-4EC4-826B-6F1E3AEE754D}"/>
               </a:ext>
             </a:extLst>
           </p:cNvPr>
@@ -37857,7 +37857,7 @@
           <p:cNvPr id="10" name="">
             <a:extLst xmlns:a="http://schemas.openxmlformats.org/drawingml/2006/main">
               <a:ext uri="{FF2B5EF4-FFF2-40B4-BE49-F238E27FC236}">
-                <a16:creationId xmlns:a16="http://schemas.microsoft.com/office/drawing/2014/main" id="{B0C04666-DECB-482E-96C2-BC5B657E8C1F}"/>
+                <a16:creationId xmlns:a16="http://schemas.microsoft.com/office/drawing/2014/main" id="{9F872AFA-0B8C-40D7-983D-4CF3F18C8000}"/>
               </a:ext>
             </a:extLst>
           </p:cNvPr>
@@ -38854,7 +38854,7 @@
                 <a:ea typeface="Apple SD Gothic Neo"/>
                 <a:cs typeface="Apple SD Gothic Neo"/>
               </a:rPr>
-              <a:t>어떤 수집 방식이 필요한가요?</a:t>
+              <a:t>Flink가 Kafka에서 읽는 것</a:t>
             </a:r>
           </a:p>
         </p:txBody>
@@ -39230,7 +39230,7 @@
           <p:cNvPr id="10" name="">
             <a:extLst xmlns:a="http://schemas.openxmlformats.org/drawingml/2006/main">
               <a:ext uri="{FF2B5EF4-FFF2-40B4-BE49-F238E27FC236}">
-                <a16:creationId xmlns:a16="http://schemas.microsoft.com/office/drawing/2014/main" id="{010C4374-9C67-46D9-80C0-9469B857FD9C}"/>
+                <a16:creationId xmlns:a16="http://schemas.microsoft.com/office/drawing/2014/main" id="{223AB543-E795-4E98-8075-FE934A72CD3C}"/>
               </a:ext>
             </a:extLst>
           </p:cNvPr>
@@ -39265,7 +39265,7 @@
                           <a:ea typeface="Apple SD Gothic Neo"/>
                           <a:cs typeface="Apple SD Gothic Neo"/>
                         </a:rPr>
-                        <a:t>방식</a:t>
+                        <a:t>입력 설계</a:t>
                       </a:r>
                     </a:p>
                   </a:txBody>
@@ -39313,7 +39313,7 @@
                           <a:ea typeface="Apple SD Gothic Neo"/>
                           <a:cs typeface="Apple SD Gothic Neo"/>
                         </a:rPr>
-                        <a:t>잘 맞는 조건</a:t>
+                        <a:t>이 예제의 설정</a:t>
                       </a:r>
                     </a:p>
                   </a:txBody>
@@ -39355,7 +39355,7 @@
                           <a:ea typeface="Apple SD Gothic Neo"/>
                           <a:cs typeface="Apple SD Gothic Neo"/>
                         </a:rPr>
-                        <a:t>설계 부담</a:t>
+                        <a:t>확인할 책임</a:t>
                       </a:r>
                     </a:p>
                   </a:txBody>
@@ -39399,7 +39399,7 @@
                           <a:ea typeface="Apple SD Gothic Neo"/>
                           <a:cs typeface="Apple SD Gothic Neo"/>
                         </a:rPr>
-                        <a:t>전체 배치</a:t>
+                        <a:t>원문 형식</a:t>
                       </a:r>
                     </a:p>
                   </a:txBody>
@@ -39441,7 +39441,7 @@
                           <a:ea typeface="Apple SD Gothic Neo"/>
                           <a:cs typeface="Apple SD Gothic Neo"/>
                         </a:rPr>
-                        <a:t>작은 범위·느린 갱신 허용</a:t>
+                        <a:t>format='raw' · payload STRING</a:t>
                       </a:r>
                     </a:p>
                   </a:txBody>
@@ -39477,7 +39477,7 @@
                           <a:ea typeface="Apple SD Gothic Neo"/>
                           <a:cs typeface="Apple SD Gothic Neo"/>
                         </a:rPr>
-                        <a:t>전체 읽기 비용과 실행 시점</a:t>
+                        <a:t>Debezium JSON을 원문으로 보존</a:t>
                       </a:r>
                     </a:p>
                   </a:txBody>
@@ -39515,7 +39515,7 @@
                           <a:ea typeface="Apple SD Gothic Neo"/>
                           <a:cs typeface="Apple SD Gothic Neo"/>
                         </a:rPr>
-                        <a:t>수정 시각 기반 증분</a:t>
+                        <a:t>전달 정보</a:t>
                       </a:r>
                     </a:p>
                   </a:txBody>
@@ -39557,7 +39557,7 @@
                           <a:ea typeface="Apple SD Gothic Neo"/>
                           <a:cs typeface="Apple SD Gothic Neo"/>
                         </a:rPr>
-                        <a:t>수정 시각·삭제 표시 신뢰 가능</a:t>
+                        <a:t>Kafka METADATA · topic/partition/offset</a:t>
                       </a:r>
                     </a:p>
                   </a:txBody>
@@ -39593,7 +39593,7 @@
                           <a:ea typeface="Apple SD Gothic Neo"/>
                           <a:cs typeface="Apple SD Gothic Neo"/>
                         </a:rPr>
-                        <a:t>경계·같은 시각·삭제 누락</a:t>
+                        <a:t>어느 메시지를 받았는지 추적</a:t>
                       </a:r>
                     </a:p>
                   </a:txBody>
@@ -39631,7 +39631,7 @@
                           <a:ea typeface="Apple SD Gothic Neo"/>
                           <a:cs typeface="Apple SD Gothic Neo"/>
                         </a:rPr>
-                        <a:t>로그 기반 CDC</a:t>
+                        <a:t>시작 위치</a:t>
                       </a:r>
                     </a:p>
                   </a:txBody>
@@ -39673,7 +39673,7 @@
                           <a:ea typeface="Apple SD Gothic Neo"/>
                           <a:cs typeface="Apple SD Gothic Neo"/>
                         </a:rPr>
-                        <a:t>수정·삭제 지속 전달과 이력 필요</a:t>
+                        <a:t>earliest-offset · 복원된 처리 상태</a:t>
                       </a:r>
                     </a:p>
                   </a:txBody>
@@ -39709,7 +39709,7 @@
                           <a:ea typeface="Apple SD Gothic Neo"/>
                           <a:cs typeface="Apple SD Gothic Neo"/>
                         </a:rPr>
-                        <a:t>WAL 보존·커넥터·재전달</a:t>
+                        <a:t>새 시작과 checkpoint 복구를 구분</a:t>
                       </a:r>
                     </a:p>
                   </a:txBody>
@@ -39933,7 +39933,7 @@
                 <a:ea typeface="Apple SD Gothic Neo"/>
                 <a:cs typeface="Apple SD Gothic Neo"/>
               </a:rPr>
-              <a:t>학습지 4번: 선택 이유와 더 단순한 대안을 함께 적습니다</a:t>
+              <a:t>Kafka 보관 → Flink 소비·적재 → Iceberg 커밋의 책임을 구분합니다</a:t>
             </a:r>
           </a:p>
         </p:txBody>
@@ -40298,7 +40298,7 @@
                 <a:ea typeface="Apple SD Gothic Neo"/>
                 <a:cs typeface="Apple SD Gothic Neo"/>
               </a:rPr>
-              <a:t>이력과 현재 상태의 저장 책임</a:t>
+              <a:t>Flink는 변경 이력을 추가합니다</a:t>
             </a:r>
           </a:p>
         </p:txBody>
@@ -40500,7 +40500,7 @@
                 <a:ea typeface="Apple SD Gothic Neo"/>
                 <a:cs typeface="Apple SD Gothic Neo"/>
               </a:rPr>
-              <a:t>Bronze 변경 이력</a:t>
+              <a:t>남길 이벤트</a:t>
             </a:r>
           </a:p>
         </p:txBody>
@@ -40668,7 +40668,7 @@
                 <a:ea typeface="Apple SD Gothic Neo"/>
                 <a:cs typeface="Apple SD Gothic Neo"/>
               </a:rPr>
-              <a:t>원문과 전달 위치 보존</a:t>
+              <a:t>payload IS NOT NULL</a:t>
             </a:r>
           </a:p>
           <a:p xmlns:a="http://schemas.openxmlformats.org/drawingml/2006/main">
@@ -40692,7 +40692,7 @@
                 <a:ea typeface="Apple SD Gothic Neo"/>
                 <a:cs typeface="Apple SD Gothic Neo"/>
               </a:rPr>
-              <a:t>다시 읽고 해석할 근거</a:t>
+              <a:t>op=d 보존 · tombstone 제외</a:t>
             </a:r>
           </a:p>
         </p:txBody>
@@ -40894,7 +40894,7 @@
                 <a:ea typeface="Apple SD Gothic Neo"/>
                 <a:cs typeface="Apple SD Gothic Neo"/>
               </a:rPr>
-              <a:t>Silver 현재 상태</a:t>
+              <a:t>적재 방식</a:t>
             </a:r>
           </a:p>
         </p:txBody>
@@ -41062,7 +41062,7 @@
                 <a:ea typeface="Apple SD Gothic Neo"/>
                 <a:cs typeface="Apple SD Gothic Neo"/>
               </a:rPr>
-              <a:t>키별 현재 값과 삭제 의미</a:t>
+              <a:t>INSERT INTO … SELECT</a:t>
             </a:r>
           </a:p>
           <a:p xmlns:a="http://schemas.openxmlformats.org/drawingml/2006/main">
@@ -41086,7 +41086,7 @@
                 <a:ea typeface="Apple SD Gothic Neo"/>
                 <a:cs typeface="Apple SD Gothic Neo"/>
               </a:rPr>
-              <a:t>반복·과거 변경의 반영 규칙</a:t>
+              <a:t>Bronze에 원문·전달 정보 append</a:t>
             </a:r>
           </a:p>
         </p:txBody>
@@ -41288,7 +41288,7 @@
                 <a:ea typeface="Apple SD Gothic Neo"/>
                 <a:cs typeface="Apple SD Gothic Neo"/>
               </a:rPr>
-              <a:t>Gold 업무 지표</a:t>
+              <a:t>후속 책임</a:t>
             </a:r>
           </a:p>
         </p:txBody>
@@ -41456,7 +41456,7 @@
                 <a:ea typeface="Apple SD Gothic Neo"/>
                 <a:cs typeface="Apple SD Gothic Neo"/>
               </a:rPr>
-              <a:t>집계 단위와 기준 시각</a:t>
+              <a:t>현재 상태는 Silver</a:t>
             </a:r>
           </a:p>
           <a:p xmlns:a="http://schemas.openxmlformats.org/drawingml/2006/main">
@@ -41480,7 +41480,7 @@
                 <a:ea typeface="Apple SD Gothic Neo"/>
                 <a:cs typeface="Apple SD Gothic Neo"/>
               </a:rPr>
-              <a:t>업무 정의에 따른 결과</a:t>
+              <a:t>업무 지표는 Gold에서 구성</a:t>
             </a:r>
           </a:p>
         </p:txBody>
@@ -41682,7 +41682,7 @@
                 <a:ea typeface="Apple SD Gothic Neo"/>
                 <a:cs typeface="Apple SD Gothic Neo"/>
               </a:rPr>
-              <a:t>학습지 5번: 각 계층이 답할 질문을 구분합니다</a:t>
+              <a:t>Bronze의 op=d는 삭제 이력 행입니다 · 업무 키의 최신 값 덮어쓰기가 아닙니다</a:t>
             </a:r>
           </a:p>
         </p:txBody>
@@ -42084,10 +42084,10 @@
       </p:grpSpPr>
       <p:sp>
         <p:nvSpPr>
-          <p:cNvPr id="14" name="text-216">
+          <p:cNvPr id="17" name="text-10">
             <a:extLst xmlns:a="http://schemas.openxmlformats.org/drawingml/2006/main">
               <a:ext uri="{FF2B5EF4-FFF2-40B4-BE49-F238E27FC236}">
-                <a16:creationId xmlns:a16="http://schemas.microsoft.com/office/drawing/2014/main" id="{BEE36A36-A18A-4175-B90F-37ED988526E9}"/>
+                <a16:creationId xmlns:a16="http://schemas.microsoft.com/office/drawing/2014/main" id="{B6B0015B-B8EA-4B4C-905F-B3F6BAFE83BF}"/>
               </a:ext>
             </a:extLst>
           </p:cNvPr>
@@ -42252,10 +42252,10 @@
       </p:sp>
       <p:sp>
         <p:nvSpPr>
-          <p:cNvPr id="2" name="text-217">
+          <p:cNvPr id="2" name="text-11">
             <a:extLst xmlns:a="http://schemas.openxmlformats.org/drawingml/2006/main">
               <a:ext uri="{FF2B5EF4-FFF2-40B4-BE49-F238E27FC236}">
-                <a16:creationId xmlns:a16="http://schemas.microsoft.com/office/drawing/2014/main" id="{F3CD2C1D-EAD3-44CA-8960-841AE322061C}"/>
+                <a16:creationId xmlns:a16="http://schemas.microsoft.com/office/drawing/2014/main" id="{082AB1B7-5E48-4855-A593-12FC0DA4CDB2}"/>
               </a:ext>
             </a:extLst>
           </p:cNvPr>
@@ -42413,17 +42413,17 @@
                 <a:ea typeface="Apple SD Gothic Neo"/>
                 <a:cs typeface="Apple SD Gothic Neo"/>
               </a:rPr>
-              <a:t>Kafka를 사이에 두는 선택</a:t>
+              <a:t>Iceberg의 기본 구조</a:t>
             </a:r>
           </a:p>
         </p:txBody>
       </p:sp>
       <p:sp>
         <p:nvSpPr>
-          <p:cNvPr id="3" name="panel-218">
+          <p:cNvPr id="3" name="panel-12">
             <a:extLst xmlns:a="http://schemas.openxmlformats.org/drawingml/2006/main">
               <a:ext uri="{FF2B5EF4-FFF2-40B4-BE49-F238E27FC236}">
-                <a16:creationId xmlns:a16="http://schemas.microsoft.com/office/drawing/2014/main" id="{92AFC05E-155A-45CE-B050-17FE09FCB6A0}"/>
+                <a16:creationId xmlns:a16="http://schemas.microsoft.com/office/drawing/2014/main" id="{6F4B333A-B93C-4C43-9A52-EACF284AA083}"/>
               </a:ext>
             </a:extLst>
           </p:cNvPr>
@@ -42435,7 +42435,7 @@
         <p:spPr>
           <a:xfrm xmlns:a="http://schemas.openxmlformats.org/drawingml/2006/main">
             <a:off x="609600" y="1943100"/>
-            <a:ext cx="5381625" cy="3028950"/>
+            <a:ext cx="3517900" cy="3028950"/>
           </a:xfrm>
           <a:prstGeom xmlns:a="http://schemas.openxmlformats.org/drawingml/2006/main" prst="roundRect">
             <a:avLst>
@@ -42454,10 +42454,10 @@
       </p:sp>
       <p:sp>
         <p:nvSpPr>
-          <p:cNvPr id="4" name="text-219">
+          <p:cNvPr id="4" name="text-13">
             <a:extLst xmlns:a="http://schemas.openxmlformats.org/drawingml/2006/main">
               <a:ext uri="{FF2B5EF4-FFF2-40B4-BE49-F238E27FC236}">
-                <a16:creationId xmlns:a16="http://schemas.microsoft.com/office/drawing/2014/main" id="{985E4EF8-558C-431B-910C-5092ED3F2B05}"/>
+                <a16:creationId xmlns:a16="http://schemas.microsoft.com/office/drawing/2014/main" id="{751251AA-5B97-46EB-A4DB-2C52C9A351D9}"/>
               </a:ext>
             </a:extLst>
           </p:cNvPr>
@@ -42469,7 +42469,7 @@
         <p:spPr>
           <a:xfrm xmlns:a="http://schemas.openxmlformats.org/drawingml/2006/main">
             <a:off x="838200" y="2209800"/>
-            <a:ext cx="4924425" cy="666750"/>
+            <a:ext cx="3060700" cy="666750"/>
           </a:xfrm>
           <a:prstGeom xmlns:a="http://schemas.openxmlformats.org/drawingml/2006/main" prst="rect">
             <a:avLst/>
@@ -42615,17 +42615,17 @@
                 <a:ea typeface="Apple SD Gothic Neo"/>
                 <a:cs typeface="Apple SD Gothic Neo"/>
               </a:rPr>
-              <a:t>얻는 것</a:t>
+              <a:t>Catalog</a:t>
             </a:r>
           </a:p>
         </p:txBody>
       </p:sp>
       <p:sp>
         <p:nvSpPr>
-          <p:cNvPr id="5" name="text-220">
+          <p:cNvPr id="5" name="text-14">
             <a:extLst xmlns:a="http://schemas.openxmlformats.org/drawingml/2006/main">
               <a:ext uri="{FF2B5EF4-FFF2-40B4-BE49-F238E27FC236}">
-                <a16:creationId xmlns:a16="http://schemas.microsoft.com/office/drawing/2014/main" id="{8773025D-9C9E-4EAC-9EB7-589098419B7B}"/>
+                <a16:creationId xmlns:a16="http://schemas.microsoft.com/office/drawing/2014/main" id="{C09D8CB6-AB44-4F96-96B5-66D8C86E9712}"/>
               </a:ext>
             </a:extLst>
           </p:cNvPr>
@@ -42637,7 +42637,7 @@
         <p:spPr>
           <a:xfrm xmlns:a="http://schemas.openxmlformats.org/drawingml/2006/main">
             <a:off x="838200" y="3086100"/>
-            <a:ext cx="4924425" cy="1714500"/>
+            <a:ext cx="3060700" cy="1714500"/>
           </a:xfrm>
           <a:prstGeom xmlns:a="http://schemas.openxmlformats.org/drawingml/2006/main" prst="rect">
             <a:avLst/>
@@ -42783,7 +42783,7 @@
                 <a:ea typeface="Apple SD Gothic Neo"/>
                 <a:cs typeface="Apple SD Gothic Neo"/>
               </a:rPr>
-              <a:t>후속 처리가 멈춰도</a:t>
+              <a:t>이름 → 메타데이터 위치</a:t>
             </a:r>
           </a:p>
           <a:p xmlns:a="http://schemas.openxmlformats.org/drawingml/2006/main">
@@ -42807,17 +42807,17 @@
                 <a:ea typeface="Apple SD Gothic Neo"/>
                 <a:cs typeface="Apple SD Gothic Neo"/>
               </a:rPr>
-              <a:t>보관 범위에서 다시 읽기</a:t>
+              <a:t>별도 PostgreSQL catalog-db</a:t>
             </a:r>
           </a:p>
         </p:txBody>
       </p:sp>
       <p:sp>
         <p:nvSpPr>
-          <p:cNvPr id="6" name="panel-221">
+          <p:cNvPr id="6" name="panel-15">
             <a:extLst xmlns:a="http://schemas.openxmlformats.org/drawingml/2006/main">
               <a:ext uri="{FF2B5EF4-FFF2-40B4-BE49-F238E27FC236}">
-                <a16:creationId xmlns:a16="http://schemas.microsoft.com/office/drawing/2014/main" id="{F483F0AD-5C28-46A0-B994-1438A4AB6A6D}"/>
+                <a16:creationId xmlns:a16="http://schemas.microsoft.com/office/drawing/2014/main" id="{0B2D55D8-9C7F-4C87-8D32-2B2FFA580709}"/>
               </a:ext>
             </a:extLst>
           </p:cNvPr>
@@ -42828,8 +42828,8 @@
         </p:nvSpPr>
         <p:spPr>
           <a:xfrm xmlns:a="http://schemas.openxmlformats.org/drawingml/2006/main">
-            <a:off x="6200775" y="1943100"/>
-            <a:ext cx="5381625" cy="3028950"/>
+            <a:off x="4337050" y="1943100"/>
+            <a:ext cx="3517900" cy="3028950"/>
           </a:xfrm>
           <a:prstGeom xmlns:a="http://schemas.openxmlformats.org/drawingml/2006/main" prst="roundRect">
             <a:avLst>
@@ -42848,10 +42848,10 @@
       </p:sp>
       <p:sp>
         <p:nvSpPr>
-          <p:cNvPr id="7" name="text-222">
+          <p:cNvPr id="7" name="text-16">
             <a:extLst xmlns:a="http://schemas.openxmlformats.org/drawingml/2006/main">
               <a:ext uri="{FF2B5EF4-FFF2-40B4-BE49-F238E27FC236}">
-                <a16:creationId xmlns:a16="http://schemas.microsoft.com/office/drawing/2014/main" id="{86678BB0-2080-461B-924F-192F0E0885F1}"/>
+                <a16:creationId xmlns:a16="http://schemas.microsoft.com/office/drawing/2014/main" id="{77318CBF-B971-485F-8400-292420FF34F7}"/>
               </a:ext>
             </a:extLst>
           </p:cNvPr>
@@ -42862,8 +42862,8 @@
         </p:nvSpPr>
         <p:spPr>
           <a:xfrm xmlns:a="http://schemas.openxmlformats.org/drawingml/2006/main">
-            <a:off x="6429375" y="2209800"/>
-            <a:ext cx="4924425" cy="666750"/>
+            <a:off x="4565650" y="2209800"/>
+            <a:ext cx="3060700" cy="666750"/>
           </a:xfrm>
           <a:prstGeom xmlns:a="http://schemas.openxmlformats.org/drawingml/2006/main" prst="rect">
             <a:avLst/>
@@ -43009,17 +43009,17 @@
                 <a:ea typeface="Apple SD Gothic Neo"/>
                 <a:cs typeface="Apple SD Gothic Neo"/>
               </a:rPr>
-              <a:t>관리할 것</a:t>
+              <a:t>Metadata</a:t>
             </a:r>
           </a:p>
         </p:txBody>
       </p:sp>
       <p:sp>
         <p:nvSpPr>
-          <p:cNvPr id="8" name="text-223">
+          <p:cNvPr id="8" name="text-17">
             <a:extLst xmlns:a="http://schemas.openxmlformats.org/drawingml/2006/main">
               <a:ext uri="{FF2B5EF4-FFF2-40B4-BE49-F238E27FC236}">
-                <a16:creationId xmlns:a16="http://schemas.microsoft.com/office/drawing/2014/main" id="{49A57845-9433-45CE-A87D-7070ED341FF7}"/>
+                <a16:creationId xmlns:a16="http://schemas.microsoft.com/office/drawing/2014/main" id="{32686024-13AE-4BA2-B7DD-D07146020C5F}"/>
               </a:ext>
             </a:extLst>
           </p:cNvPr>
@@ -43030,8 +43030,8 @@
         </p:nvSpPr>
         <p:spPr>
           <a:xfrm xmlns:a="http://schemas.openxmlformats.org/drawingml/2006/main">
-            <a:off x="6429375" y="3086100"/>
-            <a:ext cx="4924425" cy="1714500"/>
+            <a:off x="4565650" y="3086100"/>
+            <a:ext cx="3060700" cy="1714500"/>
           </a:xfrm>
           <a:prstGeom xmlns:a="http://schemas.openxmlformats.org/drawingml/2006/main" prst="rect">
             <a:avLst/>
@@ -43177,7 +43177,7 @@
                 <a:ea typeface="Apple SD Gothic Neo"/>
                 <a:cs typeface="Apple SD Gothic Neo"/>
               </a:rPr>
-              <a:t>보관 기간·처리 지연</a:t>
+              <a:t>스키마·스냅샷·파일 목록</a:t>
             </a:r>
           </a:p>
           <a:p xmlns:a="http://schemas.openxmlformats.org/drawingml/2006/main">
@@ -43201,17 +43201,411 @@
                 <a:ea typeface="Apple SD Gothic Neo"/>
                 <a:cs typeface="Apple SD Gothic Neo"/>
               </a:rPr>
-              <a:t>브로커 운영과 장애 경계</a:t>
+              <a:t>테이블을 읽는 기준</a:t>
             </a:r>
           </a:p>
         </p:txBody>
       </p:sp>
       <p:sp>
         <p:nvSpPr>
-          <p:cNvPr id="9" name="panel-224">
+          <p:cNvPr id="9" name="panel-18">
             <a:extLst xmlns:a="http://schemas.openxmlformats.org/drawingml/2006/main">
               <a:ext uri="{FF2B5EF4-FFF2-40B4-BE49-F238E27FC236}">
-                <a16:creationId xmlns:a16="http://schemas.microsoft.com/office/drawing/2014/main" id="{D231E374-ED7E-40A1-90F3-3A865AA1981C}"/>
+                <a16:creationId xmlns:a16="http://schemas.microsoft.com/office/drawing/2014/main" id="{62735B1F-9078-4105-8F7B-2BA988BF67B0}"/>
+              </a:ext>
+            </a:extLst>
+          </p:cNvPr>
+          <p:cNvSpPr>
+            <a:spLocks xmlns:a="http://schemas.openxmlformats.org/drawingml/2006/main" noGrp="1"/>
+          </p:cNvSpPr>
+          <p:nvPr/>
+        </p:nvSpPr>
+        <p:spPr>
+          <a:xfrm xmlns:a="http://schemas.openxmlformats.org/drawingml/2006/main">
+            <a:off x="8064500" y="1943100"/>
+            <a:ext cx="3517900" cy="3028950"/>
+          </a:xfrm>
+          <a:prstGeom xmlns:a="http://schemas.openxmlformats.org/drawingml/2006/main" prst="roundRect">
+            <a:avLst>
+              <a:gd name="adj" fmla="val 2830"/>
+            </a:avLst>
+          </a:prstGeom>
+          <a:solidFill xmlns:a="http://schemas.openxmlformats.org/drawingml/2006/main">
+            <a:srgbClr val="1E293B"/>
+          </a:solidFill>
+          <a:ln xmlns:a="http://schemas.openxmlformats.org/drawingml/2006/main" w="9525">
+            <a:solidFill>
+              <a:srgbClr val="334155"/>
+            </a:solidFill>
+          </a:ln>
+        </p:spPr>
+      </p:sp>
+      <p:sp>
+        <p:nvSpPr>
+          <p:cNvPr id="10" name="text-19">
+            <a:extLst xmlns:a="http://schemas.openxmlformats.org/drawingml/2006/main">
+              <a:ext uri="{FF2B5EF4-FFF2-40B4-BE49-F238E27FC236}">
+                <a16:creationId xmlns:a16="http://schemas.microsoft.com/office/drawing/2014/main" id="{EB5CE859-BCEA-411F-9600-B98DD6A79A6E}"/>
+              </a:ext>
+            </a:extLst>
+          </p:cNvPr>
+          <p:cNvSpPr>
+            <a:spLocks xmlns:a="http://schemas.openxmlformats.org/drawingml/2006/main" noGrp="1"/>
+          </p:cNvSpPr>
+          <p:nvPr/>
+        </p:nvSpPr>
+        <p:spPr>
+          <a:xfrm xmlns:a="http://schemas.openxmlformats.org/drawingml/2006/main">
+            <a:off x="8293100" y="2209800"/>
+            <a:ext cx="3060700" cy="666750"/>
+          </a:xfrm>
+          <a:prstGeom xmlns:a="http://schemas.openxmlformats.org/drawingml/2006/main" prst="rect">
+            <a:avLst/>
+          </a:prstGeom>
+          <a:noFill xmlns:a="http://schemas.openxmlformats.org/drawingml/2006/main"/>
+          <a:ln xmlns:a="http://schemas.openxmlformats.org/drawingml/2006/main" w="0">
+            <a:noFill/>
+          </a:ln>
+        </p:spPr>
+        <p:txBody>
+          <a:bodyPr xmlns:a="http://schemas.openxmlformats.org/drawingml/2006/main" wrap="square" lIns="0" tIns="0" rIns="0" bIns="0" anchor="t">
+            <a:noAutofit/>
+          </a:bodyPr>
+          <a:lstStyle xmlns:a="http://schemas.openxmlformats.org/drawingml/2006/main">
+            <a:defPPr algn="l">
+              <a:defRPr sz="2250" b="1">
+                <a:solidFill>
+                  <a:srgbClr val="22D3EE"/>
+                </a:solidFill>
+                <a:latin typeface="Apple SD Gothic Neo"/>
+                <a:ea typeface="Apple SD Gothic Neo"/>
+                <a:cs typeface="Apple SD Gothic Neo"/>
+              </a:defRPr>
+            </a:defPPr>
+            <a:lvl1pPr algn="l">
+              <a:buNone/>
+              <a:defRPr sz="2250" b="1">
+                <a:solidFill>
+                  <a:srgbClr val="22D3EE"/>
+                </a:solidFill>
+                <a:latin typeface="Apple SD Gothic Neo"/>
+                <a:ea typeface="Apple SD Gothic Neo"/>
+                <a:cs typeface="Apple SD Gothic Neo"/>
+              </a:defRPr>
+            </a:lvl1pPr>
+            <a:lvl2pPr algn="l">
+              <a:buNone/>
+              <a:defRPr sz="2250" b="1">
+                <a:solidFill>
+                  <a:srgbClr val="22D3EE"/>
+                </a:solidFill>
+                <a:latin typeface="Apple SD Gothic Neo"/>
+                <a:ea typeface="Apple SD Gothic Neo"/>
+                <a:cs typeface="Apple SD Gothic Neo"/>
+              </a:defRPr>
+            </a:lvl2pPr>
+            <a:lvl3pPr algn="l">
+              <a:buNone/>
+              <a:defRPr sz="2250" b="1">
+                <a:solidFill>
+                  <a:srgbClr val="22D3EE"/>
+                </a:solidFill>
+                <a:latin typeface="Apple SD Gothic Neo"/>
+                <a:ea typeface="Apple SD Gothic Neo"/>
+                <a:cs typeface="Apple SD Gothic Neo"/>
+              </a:defRPr>
+            </a:lvl3pPr>
+            <a:lvl4pPr algn="l">
+              <a:buNone/>
+              <a:defRPr sz="2250" b="1">
+                <a:solidFill>
+                  <a:srgbClr val="22D3EE"/>
+                </a:solidFill>
+                <a:latin typeface="Apple SD Gothic Neo"/>
+                <a:ea typeface="Apple SD Gothic Neo"/>
+                <a:cs typeface="Apple SD Gothic Neo"/>
+              </a:defRPr>
+            </a:lvl4pPr>
+            <a:lvl5pPr algn="l">
+              <a:buNone/>
+              <a:defRPr sz="2250" b="1">
+                <a:solidFill>
+                  <a:srgbClr val="22D3EE"/>
+                </a:solidFill>
+                <a:latin typeface="Apple SD Gothic Neo"/>
+                <a:ea typeface="Apple SD Gothic Neo"/>
+                <a:cs typeface="Apple SD Gothic Neo"/>
+              </a:defRPr>
+            </a:lvl5pPr>
+            <a:lvl6pPr algn="l">
+              <a:buNone/>
+              <a:defRPr sz="2250" b="1">
+                <a:solidFill>
+                  <a:srgbClr val="22D3EE"/>
+                </a:solidFill>
+                <a:latin typeface="Apple SD Gothic Neo"/>
+                <a:ea typeface="Apple SD Gothic Neo"/>
+                <a:cs typeface="Apple SD Gothic Neo"/>
+              </a:defRPr>
+            </a:lvl6pPr>
+            <a:lvl7pPr algn="l">
+              <a:buNone/>
+              <a:defRPr sz="2250" b="1">
+                <a:solidFill>
+                  <a:srgbClr val="22D3EE"/>
+                </a:solidFill>
+                <a:latin typeface="Apple SD Gothic Neo"/>
+                <a:ea typeface="Apple SD Gothic Neo"/>
+                <a:cs typeface="Apple SD Gothic Neo"/>
+              </a:defRPr>
+            </a:lvl7pPr>
+            <a:lvl8pPr algn="l">
+              <a:buNone/>
+              <a:defRPr sz="2250" b="1">
+                <a:solidFill>
+                  <a:srgbClr val="22D3EE"/>
+                </a:solidFill>
+                <a:latin typeface="Apple SD Gothic Neo"/>
+                <a:ea typeface="Apple SD Gothic Neo"/>
+                <a:cs typeface="Apple SD Gothic Neo"/>
+              </a:defRPr>
+            </a:lvl8pPr>
+            <a:lvl9pPr algn="l">
+              <a:buNone/>
+              <a:defRPr sz="2250" b="1">
+                <a:solidFill>
+                  <a:srgbClr val="22D3EE"/>
+                </a:solidFill>
+                <a:latin typeface="Apple SD Gothic Neo"/>
+                <a:ea typeface="Apple SD Gothic Neo"/>
+                <a:cs typeface="Apple SD Gothic Neo"/>
+              </a:defRPr>
+            </a:lvl9pPr>
+          </a:lstStyle>
+          <a:p xmlns:a="http://schemas.openxmlformats.org/drawingml/2006/main">
+            <a:pPr algn="l">
+              <a:buNone/>
+              <a:defRPr sz="2250" b="1">
+                <a:solidFill>
+                  <a:srgbClr val="22D3EE"/>
+                </a:solidFill>
+                <a:latin typeface="Apple SD Gothic Neo"/>
+                <a:ea typeface="Apple SD Gothic Neo"/>
+                <a:cs typeface="Apple SD Gothic Neo"/>
+              </a:defRPr>
+            </a:pPr>
+            <a:r>
+              <a:rPr sz="2250" b="1">
+                <a:solidFill>
+                  <a:srgbClr val="22D3EE"/>
+                </a:solidFill>
+                <a:latin typeface="Apple SD Gothic Neo"/>
+                <a:ea typeface="Apple SD Gothic Neo"/>
+                <a:cs typeface="Apple SD Gothic Neo"/>
+              </a:rPr>
+              <a:t>Data</a:t>
+            </a:r>
+          </a:p>
+        </p:txBody>
+      </p:sp>
+      <p:sp>
+        <p:nvSpPr>
+          <p:cNvPr id="11" name="text-20">
+            <a:extLst xmlns:a="http://schemas.openxmlformats.org/drawingml/2006/main">
+              <a:ext uri="{FF2B5EF4-FFF2-40B4-BE49-F238E27FC236}">
+                <a16:creationId xmlns:a16="http://schemas.microsoft.com/office/drawing/2014/main" id="{BF639332-1D7C-4974-BD7D-BF933B535E40}"/>
+              </a:ext>
+            </a:extLst>
+          </p:cNvPr>
+          <p:cNvSpPr>
+            <a:spLocks xmlns:a="http://schemas.openxmlformats.org/drawingml/2006/main" noGrp="1"/>
+          </p:cNvSpPr>
+          <p:nvPr/>
+        </p:nvSpPr>
+        <p:spPr>
+          <a:xfrm xmlns:a="http://schemas.openxmlformats.org/drawingml/2006/main">
+            <a:off x="8293100" y="3086100"/>
+            <a:ext cx="3060700" cy="1714500"/>
+          </a:xfrm>
+          <a:prstGeom xmlns:a="http://schemas.openxmlformats.org/drawingml/2006/main" prst="rect">
+            <a:avLst/>
+          </a:prstGeom>
+          <a:noFill xmlns:a="http://schemas.openxmlformats.org/drawingml/2006/main"/>
+          <a:ln xmlns:a="http://schemas.openxmlformats.org/drawingml/2006/main" w="0">
+            <a:noFill/>
+          </a:ln>
+        </p:spPr>
+        <p:txBody>
+          <a:bodyPr xmlns:a="http://schemas.openxmlformats.org/drawingml/2006/main" wrap="square" lIns="0" tIns="0" rIns="0" bIns="0" anchor="t">
+            <a:noAutofit/>
+          </a:bodyPr>
+          <a:lstStyle xmlns:a="http://schemas.openxmlformats.org/drawingml/2006/main">
+            <a:defPPr algn="l">
+              <a:defRPr sz="2025" b="0">
+                <a:solidFill>
+                  <a:srgbClr val="F8FAFC"/>
+                </a:solidFill>
+                <a:latin typeface="Apple SD Gothic Neo"/>
+                <a:ea typeface="Apple SD Gothic Neo"/>
+                <a:cs typeface="Apple SD Gothic Neo"/>
+              </a:defRPr>
+            </a:defPPr>
+            <a:lvl1pPr algn="l">
+              <a:buNone/>
+              <a:defRPr sz="2025" b="0">
+                <a:solidFill>
+                  <a:srgbClr val="F8FAFC"/>
+                </a:solidFill>
+                <a:latin typeface="Apple SD Gothic Neo"/>
+                <a:ea typeface="Apple SD Gothic Neo"/>
+                <a:cs typeface="Apple SD Gothic Neo"/>
+              </a:defRPr>
+            </a:lvl1pPr>
+            <a:lvl2pPr algn="l">
+              <a:buNone/>
+              <a:defRPr sz="2025" b="0">
+                <a:solidFill>
+                  <a:srgbClr val="F8FAFC"/>
+                </a:solidFill>
+                <a:latin typeface="Apple SD Gothic Neo"/>
+                <a:ea typeface="Apple SD Gothic Neo"/>
+                <a:cs typeface="Apple SD Gothic Neo"/>
+              </a:defRPr>
+            </a:lvl2pPr>
+            <a:lvl3pPr algn="l">
+              <a:buNone/>
+              <a:defRPr sz="2025" b="0">
+                <a:solidFill>
+                  <a:srgbClr val="F8FAFC"/>
+                </a:solidFill>
+                <a:latin typeface="Apple SD Gothic Neo"/>
+                <a:ea typeface="Apple SD Gothic Neo"/>
+                <a:cs typeface="Apple SD Gothic Neo"/>
+              </a:defRPr>
+            </a:lvl3pPr>
+            <a:lvl4pPr algn="l">
+              <a:buNone/>
+              <a:defRPr sz="2025" b="0">
+                <a:solidFill>
+                  <a:srgbClr val="F8FAFC"/>
+                </a:solidFill>
+                <a:latin typeface="Apple SD Gothic Neo"/>
+                <a:ea typeface="Apple SD Gothic Neo"/>
+                <a:cs typeface="Apple SD Gothic Neo"/>
+              </a:defRPr>
+            </a:lvl4pPr>
+            <a:lvl5pPr algn="l">
+              <a:buNone/>
+              <a:defRPr sz="2025" b="0">
+                <a:solidFill>
+                  <a:srgbClr val="F8FAFC"/>
+                </a:solidFill>
+                <a:latin typeface="Apple SD Gothic Neo"/>
+                <a:ea typeface="Apple SD Gothic Neo"/>
+                <a:cs typeface="Apple SD Gothic Neo"/>
+              </a:defRPr>
+            </a:lvl5pPr>
+            <a:lvl6pPr algn="l">
+              <a:buNone/>
+              <a:defRPr sz="2025" b="0">
+                <a:solidFill>
+                  <a:srgbClr val="F8FAFC"/>
+                </a:solidFill>
+                <a:latin typeface="Apple SD Gothic Neo"/>
+                <a:ea typeface="Apple SD Gothic Neo"/>
+                <a:cs typeface="Apple SD Gothic Neo"/>
+              </a:defRPr>
+            </a:lvl6pPr>
+            <a:lvl7pPr algn="l">
+              <a:buNone/>
+              <a:defRPr sz="2025" b="0">
+                <a:solidFill>
+                  <a:srgbClr val="F8FAFC"/>
+                </a:solidFill>
+                <a:latin typeface="Apple SD Gothic Neo"/>
+                <a:ea typeface="Apple SD Gothic Neo"/>
+                <a:cs typeface="Apple SD Gothic Neo"/>
+              </a:defRPr>
+            </a:lvl7pPr>
+            <a:lvl8pPr algn="l">
+              <a:buNone/>
+              <a:defRPr sz="2025" b="0">
+                <a:solidFill>
+                  <a:srgbClr val="F8FAFC"/>
+                </a:solidFill>
+                <a:latin typeface="Apple SD Gothic Neo"/>
+                <a:ea typeface="Apple SD Gothic Neo"/>
+                <a:cs typeface="Apple SD Gothic Neo"/>
+              </a:defRPr>
+            </a:lvl8pPr>
+            <a:lvl9pPr algn="l">
+              <a:buNone/>
+              <a:defRPr sz="2025" b="0">
+                <a:solidFill>
+                  <a:srgbClr val="F8FAFC"/>
+                </a:solidFill>
+                <a:latin typeface="Apple SD Gothic Neo"/>
+                <a:ea typeface="Apple SD Gothic Neo"/>
+                <a:cs typeface="Apple SD Gothic Neo"/>
+              </a:defRPr>
+            </a:lvl9pPr>
+          </a:lstStyle>
+          <a:p xmlns:a="http://schemas.openxmlformats.org/drawingml/2006/main">
+            <a:pPr algn="l">
+              <a:buNone/>
+              <a:defRPr sz="2025" b="0">
+                <a:solidFill>
+                  <a:srgbClr val="F8FAFC"/>
+                </a:solidFill>
+                <a:latin typeface="Apple SD Gothic Neo"/>
+                <a:ea typeface="Apple SD Gothic Neo"/>
+                <a:cs typeface="Apple SD Gothic Neo"/>
+              </a:defRPr>
+            </a:pPr>
+            <a:r>
+              <a:rPr sz="2025" b="0">
+                <a:solidFill>
+                  <a:srgbClr val="F8FAFC"/>
+                </a:solidFill>
+                <a:latin typeface="Apple SD Gothic Neo"/>
+                <a:ea typeface="Apple SD Gothic Neo"/>
+                <a:cs typeface="Apple SD Gothic Neo"/>
+              </a:rPr>
+              <a:t>실제 행이 담긴 Parquet</a:t>
+            </a:r>
+          </a:p>
+          <a:p xmlns:a="http://schemas.openxmlformats.org/drawingml/2006/main">
+            <a:pPr algn="l">
+              <a:buNone/>
+              <a:defRPr sz="2025" b="0">
+                <a:solidFill>
+                  <a:srgbClr val="F8FAFC"/>
+                </a:solidFill>
+                <a:latin typeface="Apple SD Gothic Neo"/>
+                <a:ea typeface="Apple SD Gothic Neo"/>
+                <a:cs typeface="Apple SD Gothic Neo"/>
+              </a:defRPr>
+            </a:pPr>
+            <a:r>
+              <a:rPr sz="2025" b="0">
+                <a:solidFill>
+                  <a:srgbClr val="F8FAFC"/>
+                </a:solidFill>
+                <a:latin typeface="Apple SD Gothic Neo"/>
+                <a:ea typeface="Apple SD Gothic Neo"/>
+                <a:cs typeface="Apple SD Gothic Neo"/>
+              </a:rPr>
+              <a:t>S3 호환 객체 저장소</a:t>
+            </a:r>
+          </a:p>
+        </p:txBody>
+      </p:sp>
+      <p:sp>
+        <p:nvSpPr>
+          <p:cNvPr id="12" name="panel-21">
+            <a:extLst xmlns:a="http://schemas.openxmlformats.org/drawingml/2006/main">
+              <a:ext uri="{FF2B5EF4-FFF2-40B4-BE49-F238E27FC236}">
+                <a16:creationId xmlns:a16="http://schemas.microsoft.com/office/drawing/2014/main" id="{196FD7CB-9990-4410-ACF1-7568C88EB3CC}"/>
               </a:ext>
             </a:extLst>
           </p:cNvPr>
@@ -43242,10 +43636,10 @@
       </p:sp>
       <p:sp>
         <p:nvSpPr>
-          <p:cNvPr id="10" name="text-225">
+          <p:cNvPr id="13" name="text-22">
             <a:extLst xmlns:a="http://schemas.openxmlformats.org/drawingml/2006/main">
               <a:ext uri="{FF2B5EF4-FFF2-40B4-BE49-F238E27FC236}">
-                <a16:creationId xmlns:a16="http://schemas.microsoft.com/office/drawing/2014/main" id="{EBB6F536-5F18-4F02-B003-16A0A3CC47C7}"/>
+                <a16:creationId xmlns:a16="http://schemas.microsoft.com/office/drawing/2014/main" id="{BFE407A2-C8C3-4B00-B5D5-7A4FCBAC77D1}"/>
               </a:ext>
             </a:extLst>
           </p:cNvPr>
@@ -43403,17 +43797,17 @@
                 <a:ea typeface="Apple SD Gothic Neo"/>
                 <a:cs typeface="Apple SD Gothic Neo"/>
               </a:rPr>
-              <a:t>학습지 5번: Kafka의 필요성과 운영 부담 한 가지씩</a:t>
+              <a:t>Flink와 Spark가 같은 Catalog를 통해 같은 테이블을 찾습니다</a:t>
             </a:r>
           </a:p>
         </p:txBody>
       </p:sp>
       <p:sp>
         <p:nvSpPr>
-          <p:cNvPr id="11" name="">
+          <p:cNvPr id="14" name="">
             <a:extLst xmlns:a="http://schemas.openxmlformats.org/drawingml/2006/main">
               <a:ext uri="{FF2B5EF4-FFF2-40B4-BE49-F238E27FC236}">
-                <a16:creationId xmlns:a16="http://schemas.microsoft.com/office/drawing/2014/main" id="{51C1DA7D-6D24-4705-BECF-C29B841B5AE5}"/>
+                <a16:creationId xmlns:a16="http://schemas.microsoft.com/office/drawing/2014/main" id="{9BA22405-4B2B-43CC-AB28-99A98CA4F207}"/>
               </a:ext>
             </a:extLst>
           </p:cNvPr>
@@ -43440,10 +43834,10 @@
       </p:sp>
       <p:sp>
         <p:nvSpPr>
-          <p:cNvPr id="12" name="text-226">
+          <p:cNvPr id="15" name="text-23">
             <a:extLst xmlns:a="http://schemas.openxmlformats.org/drawingml/2006/main">
               <a:ext uri="{FF2B5EF4-FFF2-40B4-BE49-F238E27FC236}">
-                <a16:creationId xmlns:a16="http://schemas.microsoft.com/office/drawing/2014/main" id="{1EA9EA9E-1811-4C89-B375-2587843FE269}"/>
+                <a16:creationId xmlns:a16="http://schemas.microsoft.com/office/drawing/2014/main" id="{A77E9DDC-7EBD-4AD6-B74C-6335425945A3}"/>
               </a:ext>
             </a:extLst>
           </p:cNvPr>
@@ -43608,10 +44002,10 @@
       </p:sp>
       <p:sp>
         <p:nvSpPr>
-          <p:cNvPr id="13" name="text-227">
+          <p:cNvPr id="16" name="text-24">
             <a:extLst xmlns:a="http://schemas.openxmlformats.org/drawingml/2006/main">
               <a:ext uri="{FF2B5EF4-FFF2-40B4-BE49-F238E27FC236}">
-                <a16:creationId xmlns:a16="http://schemas.microsoft.com/office/drawing/2014/main" id="{5A673288-7123-404B-B360-F8FBE9EF0D36}"/>
+                <a16:creationId xmlns:a16="http://schemas.microsoft.com/office/drawing/2014/main" id="{B46FCE60-13B5-482E-B7C5-B432A800A92C}"/>
               </a:ext>
             </a:extLst>
           </p:cNvPr>
@@ -43777,7 +44171,7 @@
     </p:spTree>
     <p:extLst>
       <p:ext uri="{BB962C8B-B14F-4D97-AF65-F5344CB8AC3E}">
-        <p14:creationId xmlns:p14="http://schemas.microsoft.com/office/powerpoint/2010/main" val="132892555"/>
+        <p14:creationId xmlns:p14="http://schemas.microsoft.com/office/powerpoint/2010/main" val="602725031"/>
       </p:ext>
     </p:extLst>
   </p:cSld>

</xml_diff>